<commit_message>
Braden and Andrew finished poster
</commit_message>
<xml_diff>
--- a/docs/Etown_Software_Engineering_Poster.pptx
+++ b/docs/Etown_Software_Engineering_Poster.pptx
@@ -165,10 +165,8 @@
 <file path=ppt/revisionInfo.xml><?xml version="1.0" encoding="utf-8"?>
 <p1510:revInfo xmlns:a="http://schemas.openxmlformats.org/drawingml/2006/main" xmlns:r="http://schemas.openxmlformats.org/officeDocument/2006/relationships" xmlns:p1510="http://schemas.microsoft.com/office/powerpoint/2015/10/main">
   <p1510:revLst>
-    <p1510:client id="{43C470D2-98B2-F6B1-04E1-B3F9791C0F13}" v="1367" dt="2025-12-10T20:02:51.935"/>
-    <p1510:client id="{9CACFDFF-FDA0-02DC-9DA9-B2D9B608A7A8}" v="9" dt="2025-12-11T14:47:35.244"/>
-    <p1510:client id="{B02DA858-2B5E-0B7D-9DA2-8B38B4DA8234}" v="245" dt="2025-12-10T22:00:54.207"/>
-    <p1510:client id="{DA56A6E9-643B-DF4A-0C12-1D9F7E413DB1}" v="459" dt="2025-12-10T19:34:13.407"/>
+    <p1510:client id="{942FB81F-FB45-A977-9C6A-31F46583A6AB}" v="23" dt="2025-12-12T22:08:27.965"/>
+    <p1510:client id="{D8315EE1-C5ED-434E-AA45-8FA123AACD9F}" v="7" dt="2025-12-12T22:43:41.858"/>
   </p1510:revLst>
 </p1510:revInfo>
 </file>
@@ -256,7 +254,7 @@
             <a:fld id="{5A0289FA-5C8D-47D8-9AF4-5913895D4286}" type="datetimeFigureOut">
               <a:rPr lang="en-US" smtClean="0"/>
               <a:pPr/>
-              <a:t>12/11/2025</a:t>
+              <a:t>12/12/2025</a:t>
             </a:fld>
             <a:endParaRPr lang="en-US"/>
           </a:p>
@@ -887,7 +885,7 @@
               <a:pPr>
                 <a:defRPr/>
               </a:pPr>
-              <a:t>12/11/2025</a:t>
+              <a:t>12/12/2025</a:t>
             </a:fld>
             <a:endParaRPr lang="en-US"/>
           </a:p>
@@ -1077,7 +1075,7 @@
               <a:pPr>
                 <a:defRPr/>
               </a:pPr>
-              <a:t>12/11/2025</a:t>
+              <a:t>12/12/2025</a:t>
             </a:fld>
             <a:endParaRPr lang="en-US"/>
           </a:p>
@@ -1277,7 +1275,7 @@
               <a:pPr>
                 <a:defRPr/>
               </a:pPr>
-              <a:t>12/11/2025</a:t>
+              <a:t>12/12/2025</a:t>
             </a:fld>
             <a:endParaRPr lang="en-US"/>
           </a:p>
@@ -1467,7 +1465,7 @@
               <a:pPr>
                 <a:defRPr/>
               </a:pPr>
-              <a:t>12/11/2025</a:t>
+              <a:t>12/12/2025</a:t>
             </a:fld>
             <a:endParaRPr lang="en-US"/>
           </a:p>
@@ -1734,7 +1732,7 @@
               <a:pPr>
                 <a:defRPr/>
               </a:pPr>
-              <a:t>12/11/2025</a:t>
+              <a:t>12/12/2025</a:t>
             </a:fld>
             <a:endParaRPr lang="en-US"/>
           </a:p>
@@ -2041,7 +2039,7 @@
               <a:pPr>
                 <a:defRPr/>
               </a:pPr>
-              <a:t>12/11/2025</a:t>
+              <a:t>12/12/2025</a:t>
             </a:fld>
             <a:endParaRPr lang="en-US"/>
           </a:p>
@@ -2487,7 +2485,7 @@
               <a:pPr>
                 <a:defRPr/>
               </a:pPr>
-              <a:t>12/11/2025</a:t>
+              <a:t>12/12/2025</a:t>
             </a:fld>
             <a:endParaRPr lang="en-US"/>
           </a:p>
@@ -2626,7 +2624,7 @@
               <a:pPr>
                 <a:defRPr/>
               </a:pPr>
-              <a:t>12/11/2025</a:t>
+              <a:t>12/12/2025</a:t>
             </a:fld>
             <a:endParaRPr lang="en-US"/>
           </a:p>
@@ -2743,7 +2741,7 @@
               <a:pPr>
                 <a:defRPr/>
               </a:pPr>
-              <a:t>12/11/2025</a:t>
+              <a:t>12/12/2025</a:t>
             </a:fld>
             <a:endParaRPr lang="en-US"/>
           </a:p>
@@ -3040,7 +3038,7 @@
               <a:pPr>
                 <a:defRPr/>
               </a:pPr>
-              <a:t>12/11/2025</a:t>
+              <a:t>12/12/2025</a:t>
             </a:fld>
             <a:endParaRPr lang="en-US"/>
           </a:p>
@@ -3317,7 +3315,7 @@
               <a:pPr>
                 <a:defRPr/>
               </a:pPr>
-              <a:t>12/11/2025</a:t>
+              <a:t>12/12/2025</a:t>
             </a:fld>
             <a:endParaRPr lang="en-US"/>
           </a:p>
@@ -3572,7 +3570,7 @@
               <a:pPr>
                 <a:defRPr/>
               </a:pPr>
-              <a:t>12/11/2025</a:t>
+              <a:t>12/12/2025</a:t>
             </a:fld>
             <a:endParaRPr lang="en-US"/>
           </a:p>
@@ -4539,7 +4537,7 @@
         <p:spPr bwMode="auto">
           <a:xfrm>
             <a:off x="11277602" y="5275416"/>
-            <a:ext cx="9772483" cy="1421223"/>
+            <a:ext cx="9772483" cy="728726"/>
           </a:xfrm>
           <a:prstGeom prst="rect">
             <a:avLst/>
@@ -4572,7 +4570,7 @@
                 <a:ea typeface="Verdana"/>
                 <a:cs typeface="Verdana" panose="020B0604030504040204" pitchFamily="34" charset="0"/>
               </a:rPr>
-              <a:t>TECHNICAL DESIGN &amp; DATA MODEL </a:t>
+              <a:t> ERD MODEL </a:t>
             </a:r>
           </a:p>
         </p:txBody>
@@ -4721,7 +4719,7 @@
         <p:spPr bwMode="auto">
           <a:xfrm>
             <a:off x="718212" y="8412479"/>
-            <a:ext cx="9157308" cy="3600986"/>
+            <a:ext cx="9157308" cy="4708981"/>
           </a:xfrm>
           <a:prstGeom prst="rect">
             <a:avLst/>
@@ -4768,7 +4766,7 @@
               <a:buChar char="•"/>
             </a:pPr>
             <a:r>
-              <a:rPr lang="en-US" sz="2400" dirty="0">
+              <a:rPr lang="en-US" sz="2800" dirty="0">
                 <a:solidFill>
                   <a:schemeClr val="bg1"/>
                 </a:solidFill>
@@ -4776,9 +4774,9 @@
                 <a:ea typeface="Verdana"/>
                 <a:cs typeface="Verdana" panose="020B0604030504040204" pitchFamily="34" charset="0"/>
               </a:rPr>
-              <a:t>The website and robotic arm had to be connected through the use of a database.</a:t>
-            </a:r>
-            <a:endParaRPr lang="en-US" sz="2400" dirty="0">
+              <a:t>The website connects to the robotic arm by using a MySQL database to hold instructions.</a:t>
+            </a:r>
+            <a:endParaRPr lang="en-US" sz="2800" dirty="0">
               <a:solidFill>
                 <a:schemeClr val="bg1"/>
               </a:solidFill>
@@ -4793,7 +4791,7 @@
               <a:buChar char="•"/>
             </a:pPr>
             <a:r>
-              <a:rPr lang="en-US" sz="2400" dirty="0">
+              <a:rPr lang="en-US" sz="2800" dirty="0">
                 <a:solidFill>
                   <a:schemeClr val="bg1"/>
                 </a:solidFill>
@@ -4801,10 +4799,10 @@
                 <a:ea typeface="Verdana"/>
                 <a:cs typeface="Verdana" panose="020B0604030504040204" pitchFamily="34" charset="0"/>
               </a:rPr>
-              <a:t>The robot had to be coded with </a:t>
-            </a:r>
-            <a:r>
-              <a:rPr lang="en-US" sz="2400" dirty="0" err="1">
+              <a:t>The robotic arm’s instructions are coded with </a:t>
+            </a:r>
+            <a:r>
+              <a:rPr lang="en-US" sz="2800" dirty="0" err="1">
                 <a:solidFill>
                   <a:schemeClr val="bg1"/>
                 </a:solidFill>
@@ -4812,10 +4810,10 @@
                 <a:ea typeface="Verdana"/>
                 <a:cs typeface="Verdana" panose="020B0604030504040204" pitchFamily="34" charset="0"/>
               </a:rPr>
-              <a:t>blockly</a:t>
-            </a:r>
-            <a:r>
-              <a:rPr lang="en-US" sz="2400" dirty="0">
+              <a:t>MyBlockly</a:t>
+            </a:r>
+            <a:r>
+              <a:rPr lang="en-US" sz="2800" dirty="0">
                 <a:solidFill>
                   <a:schemeClr val="bg1"/>
                 </a:solidFill>
@@ -4823,9 +4821,26 @@
                 <a:ea typeface="Verdana"/>
                 <a:cs typeface="Verdana" panose="020B0604030504040204" pitchFamily="34" charset="0"/>
               </a:rPr>
-              <a:t> code as well as python.</a:t>
-            </a:r>
-            <a:endParaRPr lang="en-US" sz="2400" dirty="0">
+              <a:t> code and translated into python.</a:t>
+            </a:r>
+          </a:p>
+          <a:p>
+            <a:pPr marL="457200" indent="-457200">
+              <a:buFont typeface="Arial" panose="020B0604020202020204" pitchFamily="34" charset="0"/>
+              <a:buChar char="•"/>
+            </a:pPr>
+            <a:r>
+              <a:rPr lang="en-US" sz="2800" dirty="0">
+                <a:solidFill>
+                  <a:schemeClr val="bg1"/>
+                </a:solidFill>
+                <a:latin typeface="Verdana"/>
+                <a:ea typeface="Verdana"/>
+                <a:cs typeface="Verdana" panose="020B0604030504040204" pitchFamily="34" charset="0"/>
+              </a:rPr>
+              <a:t>The website utilizes multiple coding languages including HTML, PHP, CSS, and JavaScript.</a:t>
+            </a:r>
+            <a:endParaRPr lang="en-US" sz="2800" dirty="0">
               <a:solidFill>
                 <a:schemeClr val="bg1"/>
               </a:solidFill>
@@ -4971,7 +4986,7 @@
         <p:spPr bwMode="auto">
           <a:xfrm>
             <a:off x="800974" y="4893345"/>
-            <a:ext cx="8678306" cy="1892826"/>
+            <a:ext cx="8678306" cy="3000821"/>
           </a:xfrm>
           <a:prstGeom prst="rect">
             <a:avLst/>
@@ -4985,7 +5000,7 @@
           </a:ln>
         </p:spPr>
         <p:txBody>
-          <a:bodyPr wrap="square">
+          <a:bodyPr wrap="square" lIns="91440" tIns="45720" rIns="91440" bIns="45720" anchor="t">
             <a:spAutoFit/>
           </a:bodyPr>
           <a:lstStyle/>
@@ -5000,16 +5015,27 @@
                 <a:solidFill>
                   <a:srgbClr val="004B98"/>
                 </a:solidFill>
+                <a:latin typeface="Verdana"/>
+                <a:ea typeface="Verdana"/>
+                <a:cs typeface="Verdana" panose="020B0604030504040204" pitchFamily="34" charset="0"/>
+              </a:rPr>
+              <a:t>Introduction/Purpose</a:t>
+            </a:r>
+          </a:p>
+          <a:p>
+            <a:r>
+              <a:rPr lang="en-US" sz="2400" dirty="0">
+                <a:solidFill>
+                  <a:schemeClr val="bg1"/>
+                </a:solidFill>
                 <a:latin typeface="Verdana" panose="020B0604030504040204" pitchFamily="34" charset="0"/>
                 <a:ea typeface="Verdana" panose="020B0604030504040204" pitchFamily="34" charset="0"/>
                 <a:cs typeface="Verdana" panose="020B0604030504040204" pitchFamily="34" charset="0"/>
               </a:rPr>
-              <a:t>OPPORTUNITY/PURPOSE</a:t>
-            </a:r>
-          </a:p>
-          <a:p>
-            <a:r>
-              <a:rPr lang="en-US" sz="2400" dirty="0">
+              <a:t>The </a:t>
+            </a:r>
+            <a:r>
+              <a:rPr lang="en-US" sz="2400" dirty="0" err="1">
                 <a:solidFill>
                   <a:schemeClr val="bg1"/>
                 </a:solidFill>
@@ -5017,8 +5043,34 @@
                 <a:ea typeface="Verdana" panose="020B0604030504040204" pitchFamily="34" charset="0"/>
                 <a:cs typeface="Verdana" panose="020B0604030504040204" pitchFamily="34" charset="0"/>
               </a:rPr>
-              <a:t>Problem identification, state of the art, and market. </a:t>
-            </a:r>
+              <a:t>MyCobot</a:t>
+            </a:r>
+            <a:r>
+              <a:rPr lang="en-US" sz="2400" dirty="0">
+                <a:solidFill>
+                  <a:schemeClr val="bg1"/>
+                </a:solidFill>
+                <a:latin typeface="Verdana" panose="020B0604030504040204" pitchFamily="34" charset="0"/>
+                <a:ea typeface="Verdana" panose="020B0604030504040204" pitchFamily="34" charset="0"/>
+                <a:cs typeface="Verdana" panose="020B0604030504040204" pitchFamily="34" charset="0"/>
+              </a:rPr>
+              <a:t> robotic arm and our website serve as an example of what perspective students can expect to work on while attending Elizabethtown College.</a:t>
+            </a:r>
+            <a:endParaRPr lang="en-US" sz="2400" dirty="0">
+              <a:solidFill>
+                <a:schemeClr val="bg1"/>
+              </a:solidFill>
+            </a:endParaRPr>
+          </a:p>
+          <a:p>
+            <a:endParaRPr lang="en-US" sz="2400" dirty="0">
+              <a:solidFill>
+                <a:schemeClr val="bg1"/>
+              </a:solidFill>
+              <a:latin typeface="Verdana" panose="020B0604030504040204" pitchFamily="34" charset="0"/>
+              <a:ea typeface="Verdana" panose="020B0604030504040204" pitchFamily="34" charset="0"/>
+              <a:cs typeface="Verdana" panose="020B0604030504040204" pitchFamily="34" charset="0"/>
+            </a:endParaRPr>
           </a:p>
           <a:p>
             <a:endParaRPr lang="en-US" sz="2400" dirty="0">
@@ -5252,8 +5304,8 @@
           </p:nvSpPr>
           <p:spPr>
             <a:xfrm>
-              <a:off x="2285333" y="5497576"/>
-              <a:ext cx="8624769" cy="2246139"/>
+              <a:off x="2302746" y="5166743"/>
+              <a:ext cx="8859298" cy="4177025"/>
             </a:xfrm>
             <a:prstGeom prst="rect">
               <a:avLst/>
@@ -5297,25 +5349,7 @@
                   <a:ea typeface="Verdana" panose="020B0604030504040204" pitchFamily="34" charset="0"/>
                   <a:cs typeface="Verdana" panose="020B0604030504040204" pitchFamily="34" charset="0"/>
                 </a:rPr>
-                <a:t>In 1-2 sentences, what positive impact does your project have? </a:t>
-              </a:r>
-            </a:p>
-            <a:p>
-              <a:pPr>
-                <a:spcAft>
-                  <a:spcPts val="600"/>
-                </a:spcAft>
-              </a:pPr>
-              <a:r>
-                <a:rPr lang="en-US" sz="2800" dirty="0">
-                  <a:solidFill>
-                    <a:schemeClr val="bg1"/>
-                  </a:solidFill>
-                  <a:latin typeface="Verdana" panose="020B0604030504040204" pitchFamily="34" charset="0"/>
-                  <a:ea typeface="Verdana" panose="020B0604030504040204" pitchFamily="34" charset="0"/>
-                  <a:cs typeface="Verdana" panose="020B0604030504040204" pitchFamily="34" charset="0"/>
-                </a:rPr>
-                <a:t>Environmental/climate? Social justice/equity? </a:t>
+                <a:t>The live interactive demonstration displays the academic opportunities that the Engineering and Computer Science department at Elizabethtown College provides for perspective students.</a:t>
               </a:r>
               <a:endParaRPr lang="en-US" sz="2800" dirty="0">
                 <a:solidFill>
@@ -5326,67 +5360,6 @@
           </p:txBody>
         </p:sp>
       </p:grpSp>
-      <p:sp>
-        <p:nvSpPr>
-          <p:cNvPr id="22" name="Google Shape;128;p1">
-            <a:extLst>
-              <a:ext uri="{FF2B5EF4-FFF2-40B4-BE49-F238E27FC236}">
-                <a16:creationId xmlns:a16="http://schemas.microsoft.com/office/drawing/2014/main" id="{D32BA0E8-46A5-D037-8A23-8F0B287020B9}"/>
-              </a:ext>
-            </a:extLst>
-          </p:cNvPr>
-          <p:cNvSpPr/>
-          <p:nvPr/>
-        </p:nvSpPr>
-        <p:spPr>
-          <a:xfrm rot="20844414">
-            <a:off x="7076416" y="12218818"/>
-            <a:ext cx="4805728" cy="2059823"/>
-          </a:xfrm>
-          <a:prstGeom prst="rect">
-            <a:avLst/>
-          </a:prstGeom>
-          <a:solidFill>
-            <a:srgbClr val="3DB5E6"/>
-          </a:solidFill>
-          <a:ln>
-            <a:noFill/>
-          </a:ln>
-        </p:spPr>
-        <p:txBody>
-          <a:bodyPr spcFirstLastPara="1" wrap="square" lIns="83806" tIns="41892" rIns="83806" bIns="41892" anchor="t" anchorCtr="0">
-            <a:spAutoFit/>
-          </a:bodyPr>
-          <a:lstStyle/>
-          <a:p>
-            <a:pPr algn="ctr"/>
-            <a:r>
-              <a:rPr lang="en-US" sz="2567" b="1" dirty="0">
-                <a:solidFill>
-                  <a:schemeClr val="bg1"/>
-                </a:solidFill>
-              </a:rPr>
-              <a:t>You can ‘Color outside the lines’ to emphasize a key point. For example,</a:t>
-            </a:r>
-          </a:p>
-          <a:p>
-            <a:pPr algn="ctr"/>
-            <a:r>
-              <a:rPr lang="en-US" sz="2567" b="1" dirty="0">
-                <a:solidFill>
-                  <a:schemeClr val="bg1"/>
-                </a:solidFill>
-              </a:rPr>
-              <a:t>Fun Fact: The system is designed to …</a:t>
-            </a:r>
-            <a:endParaRPr sz="2567" b="1" dirty="0">
-              <a:solidFill>
-                <a:schemeClr val="bg1"/>
-              </a:solidFill>
-            </a:endParaRPr>
-          </a:p>
-        </p:txBody>
-      </p:sp>
       <p:sp>
         <p:nvSpPr>
           <p:cNvPr id="24" name="TextBox 23">
@@ -5402,7 +5375,7 @@
         <p:spPr>
           <a:xfrm>
             <a:off x="718212" y="15048719"/>
-            <a:ext cx="18606108" cy="2785378"/>
+            <a:ext cx="20509176" cy="2416046"/>
           </a:xfrm>
           <a:prstGeom prst="rect">
             <a:avLst/>
@@ -5410,7 +5383,7 @@
           <a:noFill/>
         </p:spPr>
         <p:txBody>
-          <a:bodyPr wrap="square">
+          <a:bodyPr wrap="square" lIns="91440" tIns="45720" rIns="91440" bIns="45720" anchor="t">
             <a:spAutoFit/>
           </a:bodyPr>
           <a:lstStyle/>
@@ -5428,11 +5401,11 @@
                 <a:solidFill>
                   <a:srgbClr val="004B98"/>
                 </a:solidFill>
-                <a:latin typeface="Verdana" panose="020B0604030504040204" pitchFamily="34" charset="0"/>
-                <a:ea typeface="Verdana" panose="020B0604030504040204" pitchFamily="34" charset="0"/>
+                <a:latin typeface="Verdana"/>
+                <a:ea typeface="Verdana"/>
                 <a:cs typeface="Verdana" panose="020B0604030504040204" pitchFamily="34" charset="0"/>
               </a:rPr>
-              <a:t>PROTOTYPE/PROCESS</a:t>
+              <a:t>Key Features</a:t>
             </a:r>
             <a:endParaRPr lang="en-US" sz="4400" b="1" dirty="0">
               <a:solidFill>
@@ -5445,7 +5418,7 @@
           </a:p>
           <a:p>
             <a:r>
-              <a:rPr lang="en-US" sz="4000" dirty="0">
+              <a:rPr lang="en-US" sz="3200" dirty="0">
                 <a:solidFill>
                   <a:schemeClr val="bg1"/>
                 </a:solidFill>
@@ -5453,9 +5426,9 @@
                 <a:ea typeface="Verdana" panose="020B0604030504040204" pitchFamily="34" charset="0"/>
                 <a:cs typeface="Verdana" panose="020B0604030504040204" pitchFamily="34" charset="0"/>
               </a:rPr>
-              <a:t>The project’s main feature on the website is located on the Special Controls page. The images on the page can be clicked to send directions to the robot to perform in real time.</a:t>
-            </a:r>
-            <a:endParaRPr lang="en-US" sz="5400" b="1" dirty="0">
+              <a:t>The project’s main feature on the website is located on the Special Controls page. The robotic arm is loaded with five preprogrammed instructions to perform. Each image on the page can be clicked to send directions to the robot to perform in real time based on its corresponding caption.</a:t>
+            </a:r>
+            <a:endParaRPr lang="en-US" sz="3200" b="1" dirty="0">
               <a:solidFill>
                 <a:schemeClr val="bg1"/>
               </a:solidFill>
@@ -5541,7 +5514,7 @@
         </p:blipFill>
         <p:spPr>
           <a:xfrm>
-            <a:off x="12047409" y="6705583"/>
+            <a:off x="12047409" y="6442762"/>
             <a:ext cx="8162365" cy="7678024"/>
           </a:xfrm>
           <a:prstGeom prst="rect">
@@ -6122,6 +6095,53 @@
           <a:prstGeom prst="rect">
             <a:avLst/>
           </a:prstGeom>
+        </p:spPr>
+      </p:pic>
+      <p:pic>
+        <p:nvPicPr>
+          <p:cNvPr id="1026" name="Picture 2" descr="A white pipe with a black screen&#10;&#10;AI-generated content may be incorrect.">
+            <a:extLst>
+              <a:ext uri="{FF2B5EF4-FFF2-40B4-BE49-F238E27FC236}">
+                <a16:creationId xmlns:a16="http://schemas.microsoft.com/office/drawing/2014/main" id="{6186A77F-D86D-76BF-BD24-76B30F47CE79}"/>
+              </a:ext>
+            </a:extLst>
+          </p:cNvPr>
+          <p:cNvPicPr>
+            <a:picLocks noChangeAspect="1" noChangeArrowheads="1"/>
+          </p:cNvPicPr>
+          <p:nvPr/>
+        </p:nvPicPr>
+        <p:blipFill>
+          <a:blip r:embed="rId9">
+            <a:extLst>
+              <a:ext uri="{28A0092B-C50C-407E-A947-70E740481C1C}">
+                <a14:useLocalDpi xmlns:a14="http://schemas.microsoft.com/office/drawing/2010/main" val="0"/>
+              </a:ext>
+            </a:extLst>
+          </a:blip>
+          <a:srcRect/>
+          <a:stretch>
+            <a:fillRect/>
+          </a:stretch>
+        </p:blipFill>
+        <p:spPr bwMode="auto">
+          <a:xfrm>
+            <a:off x="9875520" y="18027377"/>
+            <a:ext cx="3585117" cy="3585117"/>
+          </a:xfrm>
+          <a:prstGeom prst="rect">
+            <a:avLst/>
+          </a:prstGeom>
+          <a:noFill/>
+          <a:extLst>
+            <a:ext uri="{909E8E84-426E-40DD-AFC4-6F175D3DCCD1}">
+              <a14:hiddenFill xmlns:a14="http://schemas.microsoft.com/office/drawing/2010/main">
+                <a:solidFill>
+                  <a:srgbClr val="FFFFFF"/>
+                </a:solidFill>
+              </a14:hiddenFill>
+            </a:ext>
+          </a:extLst>
         </p:spPr>
       </p:pic>
     </p:spTree>
@@ -6699,6 +6719,15 @@
 </file>
 
 <file path=customXml/item1.xml><?xml version="1.0" encoding="utf-8"?>
+<?mso-contentType ?>
+<FormTemplates xmlns="http://schemas.microsoft.com/sharepoint/v3/contenttype/forms">
+  <Display>DocumentLibraryForm</Display>
+  <Edit>DocumentLibraryForm</Edit>
+  <New>DocumentLibraryForm</New>
+</FormTemplates>
+</file>
+
+<file path=customXml/item2.xml><?xml version="1.0" encoding="utf-8"?>
 <ct:contentTypeSchema xmlns:ct="http://schemas.microsoft.com/office/2006/metadata/contentType" xmlns:ma="http://schemas.microsoft.com/office/2006/metadata/properties/metaAttributes" ct:_="" ma:_="" ma:contentTypeName="Document" ma:contentTypeID="0x0101008EFA95D5A453204B82B388E0EAEB7722" ma:contentTypeVersion="17" ma:contentTypeDescription="Create a new document." ma:contentTypeScope="" ma:versionID="dda70ad3042d19a9677b7138053d1fa9">
   <xsd:schema xmlns:xsd="http://www.w3.org/2001/XMLSchema" xmlns:xs="http://www.w3.org/2001/XMLSchema" xmlns:p="http://schemas.microsoft.com/office/2006/metadata/properties" xmlns:ns2="fab6ae7d-06c6-440f-bba1-9caa7231207d" xmlns:ns3="c875c36d-ac51-4e84-9442-bee5089cbcea" targetNamespace="http://schemas.microsoft.com/office/2006/metadata/properties" ma:root="true" ma:fieldsID="98010f272a5ba5ef2e8b4481ca434998" ns2:_="" ns3:_="">
     <xsd:import namespace="fab6ae7d-06c6-440f-bba1-9caa7231207d"/>
@@ -6947,15 +6976,6 @@
 </ct:contentTypeSchema>
 </file>
 
-<file path=customXml/item2.xml><?xml version="1.0" encoding="utf-8"?>
-<?mso-contentType ?>
-<FormTemplates xmlns="http://schemas.microsoft.com/sharepoint/v3/contenttype/forms">
-  <Display>DocumentLibraryForm</Display>
-  <Edit>DocumentLibraryForm</Edit>
-  <New>DocumentLibraryForm</New>
-</FormTemplates>
-</file>
-
 <file path=customXml/item3.xml><?xml version="1.0" encoding="utf-8"?>
 <p:properties xmlns:p="http://schemas.microsoft.com/office/2006/metadata/properties" xmlns:xsi="http://www.w3.org/2001/XMLSchema-instance" xmlns:pc="http://schemas.microsoft.com/office/infopath/2007/PartnerControls">
   <documentManagement>
@@ -6976,6 +6996,14 @@
 </file>
 
 <file path=customXml/itemProps1.xml><?xml version="1.0" encoding="utf-8"?>
+<ds:datastoreItem xmlns:ds="http://schemas.openxmlformats.org/officeDocument/2006/customXml" ds:itemID="{EA638ADA-06DF-45AB-BFB2-D0D6F294C0ED}">
+  <ds:schemaRefs>
+    <ds:schemaRef ds:uri="http://schemas.microsoft.com/sharepoint/v3/contenttype/forms"/>
+  </ds:schemaRefs>
+</ds:datastoreItem>
+</file>
+
+<file path=customXml/itemProps2.xml><?xml version="1.0" encoding="utf-8"?>
 <ds:datastoreItem xmlns:ds="http://schemas.openxmlformats.org/officeDocument/2006/customXml" ds:itemID="{32646343-FA08-41DE-B0D1-4C7CF84D7151}">
   <ds:schemaRefs>
     <ds:schemaRef ds:uri="http://schemas.microsoft.com/office/2006/metadata/contentType"/>
@@ -6994,21 +7022,19 @@
 </ds:datastoreItem>
 </file>
 
-<file path=customXml/itemProps2.xml><?xml version="1.0" encoding="utf-8"?>
-<ds:datastoreItem xmlns:ds="http://schemas.openxmlformats.org/officeDocument/2006/customXml" ds:itemID="{EA638ADA-06DF-45AB-BFB2-D0D6F294C0ED}">
-  <ds:schemaRefs>
-    <ds:schemaRef ds:uri="http://schemas.microsoft.com/sharepoint/v3/contenttype/forms"/>
-  </ds:schemaRefs>
-</ds:datastoreItem>
-</file>
-
 <file path=customXml/itemProps3.xml><?xml version="1.0" encoding="utf-8"?>
 <ds:datastoreItem xmlns:ds="http://schemas.openxmlformats.org/officeDocument/2006/customXml" ds:itemID="{3A28B7BE-1EEF-4846-B0EC-E672D97B7FFD}">
   <ds:schemaRefs>
+    <ds:schemaRef ds:uri="http://purl.org/dc/dcmitype/"/>
+    <ds:schemaRef ds:uri="fab6ae7d-06c6-440f-bba1-9caa7231207d"/>
+    <ds:schemaRef ds:uri="http://schemas.microsoft.com/office/2006/documentManagement/types"/>
+    <ds:schemaRef ds:uri="http://www.w3.org/XML/1998/namespace"/>
+    <ds:schemaRef ds:uri="http://schemas.microsoft.com/office/infopath/2007/PartnerControls"/>
+    <ds:schemaRef ds:uri="http://schemas.openxmlformats.org/package/2006/metadata/core-properties"/>
+    <ds:schemaRef ds:uri="http://purl.org/dc/elements/1.1/"/>
+    <ds:schemaRef ds:uri="c875c36d-ac51-4e84-9442-bee5089cbcea"/>
     <ds:schemaRef ds:uri="http://schemas.microsoft.com/office/2006/metadata/properties"/>
-    <ds:schemaRef ds:uri="http://schemas.microsoft.com/office/infopath/2007/PartnerControls"/>
-    <ds:schemaRef ds:uri="c875c36d-ac51-4e84-9442-bee5089cbcea"/>
-    <ds:schemaRef ds:uri="fab6ae7d-06c6-440f-bba1-9caa7231207d"/>
+    <ds:schemaRef ds:uri="http://purl.org/dc/terms/"/>
   </ds:schemaRefs>
 </ds:datastoreItem>
 </file>
</xml_diff>